<commit_message>
fix: preserve explainer typography and output
</commit_message>
<xml_diff>
--- a/data/model/random-forest-three-level-explainer.pptx
+++ b/data/model/random-forest-three-level-explainer.pptx
@@ -3170,6 +3170,7 @@
                   <a:srgbClr val="132338"/>
                 </a:solidFill>
                 <a:latin typeface="Microsoft JhengHei"/>
+                <a:ea typeface="Microsoft JhengHei"/>
               </a:rPr>
               <a:t>隨機森林如何判斷最大震度？</a:t>
             </a:r>
@@ -3205,6 +3206,7 @@
                   <a:srgbClr val="667280"/>
                 </a:solidFill>
                 <a:latin typeface="Microsoft JhengHei"/>
+                <a:ea typeface="Microsoft JhengHei"/>
               </a:rPr>
               <a:t>代表樹第 8 棵｜以下為模型真實前三層判斷規則</a:t>
             </a:r>
@@ -3275,6 +3277,7 @@
                   <a:srgbClr val="1F807D"/>
                 </a:solidFill>
                 <a:latin typeface="Microsoft JhengHei"/>
+                <a:ea typeface="Microsoft JhengHei"/>
               </a:rPr>
               <a:t>是（≤）</a:t>
             </a:r>
@@ -3345,6 +3348,7 @@
                   <a:srgbClr val="1F807D"/>
                 </a:solidFill>
                 <a:latin typeface="Microsoft JhengHei"/>
+                <a:ea typeface="Microsoft JhengHei"/>
               </a:rPr>
               <a:t>是（≤）</a:t>
             </a:r>
@@ -3415,6 +3419,7 @@
                   <a:srgbClr val="DA9335"/>
                 </a:solidFill>
                 <a:latin typeface="Microsoft JhengHei"/>
+                <a:ea typeface="Microsoft JhengHei"/>
               </a:rPr>
               <a:t>否（&gt;）</a:t>
             </a:r>
@@ -3485,6 +3490,7 @@
                   <a:srgbClr val="DA9335"/>
                 </a:solidFill>
                 <a:latin typeface="Microsoft JhengHei"/>
+                <a:ea typeface="Microsoft JhengHei"/>
               </a:rPr>
               <a:t>否（&gt;）</a:t>
             </a:r>
@@ -3555,6 +3561,7 @@
                   <a:srgbClr val="1F807D"/>
                 </a:solidFill>
                 <a:latin typeface="Microsoft JhengHei"/>
+                <a:ea typeface="Microsoft JhengHei"/>
               </a:rPr>
               <a:t>是（≤）</a:t>
             </a:r>
@@ -3625,6 +3632,7 @@
                   <a:srgbClr val="DA9335"/>
                 </a:solidFill>
                 <a:latin typeface="Microsoft JhengHei"/>
+                <a:ea typeface="Microsoft JhengHei"/>
               </a:rPr>
               <a:t>否（&gt;）</a:t>
             </a:r>
@@ -3679,6 +3687,7 @@
                   <a:srgbClr val="FFFFFF"/>
                 </a:solidFill>
                 <a:latin typeface="Microsoft JhengHei"/>
+                <a:ea typeface="Microsoft JhengHei"/>
               </a:rPr>
               <a:t>震級 ≤ 4.65？
 樣本 8,577｜目前偏向震度 4</a:t>
@@ -3734,6 +3743,7 @@
                   <a:srgbClr val="FFFFFF"/>
                 </a:solidFill>
                 <a:latin typeface="Microsoft JhengHei"/>
+                <a:ea typeface="Microsoft JhengHei"/>
               </a:rPr>
               <a:t>月份 ≤ 8.50？
 樣本 7,554｜目前偏向震度 0</a:t>
@@ -3789,6 +3799,7 @@
                   <a:srgbClr val="222B36"/>
                 </a:solidFill>
                 <a:latin typeface="Microsoft JhengHei"/>
+                <a:ea typeface="Microsoft JhengHei"/>
               </a:rPr>
               <a:t>深度 ≤ 21.25？
 樣本 5,105｜目前偏向震度 3</a:t>
@@ -3844,6 +3855,7 @@
                   <a:srgbClr val="222B36"/>
                 </a:solidFill>
                 <a:latin typeface="Microsoft JhengHei"/>
+                <a:ea typeface="Microsoft JhengHei"/>
               </a:rPr>
               <a:t>時刻 ≤ 10.50？
 樣本 2,449｜目前偏向震度 0</a:t>
@@ -3899,6 +3911,7 @@
                   <a:srgbClr val="FFFFFF"/>
                 </a:solidFill>
                 <a:latin typeface="Microsoft JhengHei"/>
+                <a:ea typeface="Microsoft JhengHei"/>
               </a:rPr>
               <a:t>月份 ≤ 8.50？
 樣本 1,023｜目前偏向震度 6</a:t>
@@ -3954,6 +3967,7 @@
                   <a:srgbClr val="222B36"/>
                 </a:solidFill>
                 <a:latin typeface="Microsoft JhengHei"/>
+                <a:ea typeface="Microsoft JhengHei"/>
               </a:rPr>
               <a:t>時刻 ≤ 18.50？
 樣本 664｜目前偏向震度 6</a:t>
@@ -4009,6 +4023,7 @@
                   <a:srgbClr val="222B36"/>
                 </a:solidFill>
                 <a:latin typeface="Microsoft JhengHei"/>
+                <a:ea typeface="Microsoft JhengHei"/>
               </a:rPr>
               <a:t>震級 ≤ 6.15？
 樣本 359｜目前偏向震度 7</a:t>
@@ -4090,6 +4105,7 @@
                   <a:srgbClr val="FFFFFF"/>
                 </a:solidFill>
                 <a:latin typeface="Microsoft JhengHei"/>
+                <a:ea typeface="Microsoft JhengHei"/>
               </a:rPr>
               <a:t>這只是 200 棵樹中的一棵。每棵樹各自判斷，最後由所有樹投票決定分類結果。</a:t>
             </a:r>
@@ -4125,6 +4141,7 @@
                   <a:srgbClr val="667280"/>
                 </a:solidFill>
                 <a:latin typeface="Microsoft JhengHei"/>
+                <a:ea typeface="Microsoft JhengHei"/>
               </a:rPr>
               <a:t>前三層只呈現模型早期的主要切分，不代表完整模型；本模型是最大震度分類，不是地震預測。</a:t>
             </a:r>

</xml_diff>